<commit_message>
Mini-progetto finale a casa: soluzioni, dispense e slide complete di L7, L8, E4
Co-Authored-By: Claude Opus 5.5 <noreply@anthropic.com>
Claude-Session: https://claude.ai/code/session_014CzWDFXvYNxqLeD99LSN3G
</commit_message>
<xml_diff>
--- a/L07_internet_regressione/slide_complete.pptx
+++ b/L07_internet_regressione/slide_complete.pptx
@@ -116,32 +116,32 @@
   <p:extLst>
     <p:ext uri="{521415D9-36F7-43E2-AB2F-B90AF26B5E84}">
       <p14:sectionLst xmlns:p14="http://schemas.microsoft.com/office/powerpoint/2010/main">
-        <p14:section name="Apertura" id="{98e2cd42-c7fb-997d-ac0d-c2e8a3db79f3}">
+        <p14:section name="Apertura" id="{bf47d49d-2cc0-7357-2da5-c727513767f9}">
           <p14:sldIdLst>
             <p14:sldId id="256"/>
             <p14:sldId id="257"/>
           </p14:sldIdLst>
         </p14:section>
-        <p14:section name="Spiegazione" id="{6ac17daf-6046-a039-2312-1c54558d3f14}">
+        <p14:section name="Spiegazione" id="{c90d093f-dd73-7907-4ad4-b373587542ad}">
           <p14:sldIdLst>
             <p14:sldId id="258"/>
             <p14:sldId id="259"/>
             <p14:sldId id="260"/>
           </p14:sldIdLst>
         </p14:section>
-        <p14:section name="Task" id="{539fd281-d60b-5697-45d3-58bdd7c041cd}">
+        <p14:section name="Task" id="{db88b6df-70b9-7452-8ed3-e4dc31e754ee}">
           <p14:sldIdLst>
             <p14:sldId id="261"/>
           </p14:sldIdLst>
         </p14:section>
-        <p14:section name="Debrief" id="{27c7bf81-feb8-82c4-3397-496ffc78447f}">
+        <p14:section name="Debrief" id="{c530485a-3987-04e4-dd13-369970963c7b}">
           <p14:sldIdLst>
             <p14:sldId id="262"/>
             <p14:sldId id="263"/>
             <p14:sldId id="264"/>
           </p14:sldIdLst>
         </p14:section>
-        <p14:section name="Chiusura" id="{87ca117a-c669-1234-17fa-abb5fd8b2d5d}">
+        <p14:section name="Chiusura" id="{bc6d6c8a-1210-8355-269a-eb1c8998bcfd}">
           <p14:sldIdLst>
             <p14:sldId id="265"/>
           </p14:sldIdLst>
@@ -2299,7 +2299,7 @@
                   <a:srgbClr val="F4C06E"/>
                 </a:solidFill>
               </a:rPr>
-              <a:t>Pensa a una domanda per il mini-progetto finale</a:t>
+              <a:t>Compito: scegliete domanda e dati per il mini-progetto</a:t>
             </a:r>
             <a:endParaRPr lang="en-US" sz="2200" dirty="0"/>
           </a:p>

</xml_diff>